<commit_message>
Discover: real OFF product photos on top items; light-theme decks
App:
- Add a curated DISCOVER_FEATURED set of real Open Food Facts products (real
  barcodes, real Nutri-Score, real front photos) that rank first on the Popular
  leaderboard, so the top reads like genuine scanned products instead of emoji.
  Photos load from OFF's CDN via <img> with an emoji fallback (offline / 404).
- New .disc-photo style; seeded sort surfaces photo items first. SW cache v236.

Decks (both firSTep + Infomatrix):
- Convert the whole deck to the light/white theme (title, See-it, tour and close
  slides flipped from dark green to cream; dark accent strips recoloured green).
- Re-capture all app screenshots in light theme, including the Discover
  leaderboard with real OFF photos; the tour now shows recipes + per-item edit.

Co-Authored-By: Claude Opus 4.8 <noreply@anthropic.com>
Claude-Session: https://claude.ai/code/session_017d9cbJJ4cKEAZ38GrGQcBx
</commit_message>
<xml_diff>
--- a/docs/Kulpio_Infomatrix.pptx
+++ b/docs/Kulpio_Infomatrix.pptx
@@ -1396,7 +1396,7 @@
           <a:p>
             <a:r>
               <a:rPr lang="en-US" dirty="0"/>
-              <a:t>Real screenshots: the scanned product card, the impact screen, and the shared-fridge chat. Everything runs offline from a single HTML file.</a:t>
+              <a:t>Real screenshots: the scanned product card with an allergen warning, the impact screen, and the community Discover leaderboard. Everything runs offline from a single HTML file.</a:t>
             </a:r>
             <a:endParaRPr lang="en-US" dirty="0"/>
           </a:p>
@@ -1484,7 +1484,7 @@
           <a:p>
             <a:r>
               <a:rPr lang="en-US" dirty="0"/>
-              <a:t>A quick product tour: the home dashboard, the shared-fridge setup, the privacy/data controls, and the profile with levels and impact.</a:t>
+              <a:t>A quick product tour: the home dashboard, recipes from your ingredients, the per-item edit with price history, and the profile with levels and impact.</a:t>
             </a:r>
             <a:endParaRPr lang="en-US" dirty="0"/>
           </a:p>
@@ -2103,7 +2103,7 @@
     <p:bg>
       <p:bgPr>
         <a:solidFill>
-          <a:srgbClr val="0E1C12"/>
+          <a:srgbClr val="F4F7EF"/>
         </a:solidFill>
       </p:bgPr>
     </p:bg>
@@ -2129,14 +2129,14 @@
         </p:nvSpPr>
         <p:spPr>
           <a:xfrm>
-            <a:off x="9235440" y="-1737360"/>
-            <a:ext cx="5120640" cy="5120640"/>
+            <a:off x="10835640" y="5349240"/>
+            <a:ext cx="3200400" cy="3200400"/>
           </a:xfrm>
           <a:prstGeom prst="ellipse">
             <a:avLst/>
           </a:prstGeom>
           <a:solidFill>
-            <a:srgbClr val="1F5D33"/>
+            <a:srgbClr val="ECF3DF"/>
           </a:solidFill>
           <a:ln/>
         </p:spPr>
@@ -2149,41 +2149,21 @@
         </p:nvSpPr>
         <p:spPr>
           <a:xfrm>
-            <a:off x="10972800" y="2651760"/>
-            <a:ext cx="2011680" cy="2011680"/>
+            <a:off x="-868680" y="-868680"/>
+            <a:ext cx="2103120" cy="2103120"/>
           </a:xfrm>
           <a:prstGeom prst="ellipse">
             <a:avLst/>
           </a:prstGeom>
           <a:solidFill>
-            <a:srgbClr val="18301C"/>
-          </a:solidFill>
-          <a:ln/>
-        </p:spPr>
-      </p:sp>
-      <p:sp>
-        <p:nvSpPr>
-          <p:cNvPr id="4" name="Shape 2"/>
-          <p:cNvSpPr/>
-          <p:nvPr/>
-        </p:nvSpPr>
-        <p:spPr>
-          <a:xfrm>
-            <a:off x="10195560" y="1600200"/>
-            <a:ext cx="457200" cy="457200"/>
-          </a:xfrm>
-          <a:prstGeom prst="ellipse">
-            <a:avLst/>
-          </a:prstGeom>
-          <a:solidFill>
-            <a:srgbClr val="B5E048"/>
-          </a:solidFill>
-          <a:ln/>
-        </p:spPr>
-      </p:sp>
-      <p:sp>
-        <p:nvSpPr>
-          <p:cNvPr id="5" name="Text 3"/>
+            <a:srgbClr val="EDF3E2"/>
+          </a:solidFill>
+          <a:ln/>
+        </p:spPr>
+      </p:sp>
+      <p:sp>
+        <p:nvSpPr>
+          <p:cNvPr id="4" name="Text 2"/>
           <p:cNvSpPr/>
           <p:nvPr/>
         </p:nvSpPr>
@@ -2219,7 +2199,7 @@
       </p:sp>
       <p:sp>
         <p:nvSpPr>
-          <p:cNvPr id="6" name="Text 4"/>
+          <p:cNvPr id="5" name="Text 3"/>
           <p:cNvSpPr/>
           <p:nvPr/>
         </p:nvSpPr>
@@ -2244,7 +2224,7 @@
             <a:r>
               <a:rPr lang="en-US" sz="7000" b="1" dirty="0">
                 <a:solidFill>
-                  <a:srgbClr val="FFFFFF"/>
+                  <a:srgbClr val="1F5D33"/>
                 </a:solidFill>
                 <a:latin typeface="Calibri" pitchFamily="34" charset="0"/>
                 <a:ea typeface="Calibri" pitchFamily="34" charset="-122"/>
@@ -2258,7 +2238,7 @@
       </p:sp>
       <p:sp>
         <p:nvSpPr>
-          <p:cNvPr id="7" name="Text 5"/>
+          <p:cNvPr id="6" name="Text 4"/>
           <p:cNvSpPr/>
           <p:nvPr/>
         </p:nvSpPr>
@@ -2283,7 +2263,7 @@
             <a:r>
               <a:rPr lang="en-US" sz="2300" b="1" dirty="0">
                 <a:solidFill>
-                  <a:srgbClr val="B5E048"/>
+                  <a:srgbClr val="2C6E3F"/>
                 </a:solidFill>
                 <a:latin typeface="Calibri" pitchFamily="34" charset="0"/>
                 <a:ea typeface="Calibri" pitchFamily="34" charset="-122"/>
@@ -2297,7 +2277,7 @@
       </p:sp>
       <p:sp>
         <p:nvSpPr>
-          <p:cNvPr id="8" name="Text 6"/>
+          <p:cNvPr id="7" name="Text 5"/>
           <p:cNvSpPr/>
           <p:nvPr/>
         </p:nvSpPr>
@@ -2325,7 +2305,7 @@
             <a:r>
               <a:rPr lang="en-US" sz="1500" dirty="0">
                 <a:solidFill>
-                  <a:srgbClr val="CBD8C2"/>
+                  <a:srgbClr val="5B6B57"/>
                 </a:solidFill>
                 <a:latin typeface="Calibri" pitchFamily="34" charset="0"/>
                 <a:ea typeface="Calibri" pitchFamily="34" charset="-122"/>
@@ -2339,7 +2319,7 @@
       </p:sp>
       <p:sp>
         <p:nvSpPr>
-          <p:cNvPr id="9" name="Shape 7"/>
+          <p:cNvPr id="8" name="Shape 6"/>
           <p:cNvSpPr/>
           <p:nvPr/>
         </p:nvSpPr>
@@ -2361,7 +2341,7 @@
       </p:sp>
       <p:sp>
         <p:nvSpPr>
-          <p:cNvPr id="10" name="Text 8"/>
+          <p:cNvPr id="9" name="Text 7"/>
           <p:cNvSpPr/>
           <p:nvPr/>
         </p:nvSpPr>
@@ -2400,7 +2380,7 @@
       </p:sp>
       <p:sp>
         <p:nvSpPr>
-          <p:cNvPr id="11" name="Shape 9"/>
+          <p:cNvPr id="10" name="Shape 8"/>
           <p:cNvSpPr/>
           <p:nvPr/>
         </p:nvSpPr>
@@ -2422,7 +2402,7 @@
       </p:sp>
       <p:sp>
         <p:nvSpPr>
-          <p:cNvPr id="12" name="Text 10"/>
+          <p:cNvPr id="11" name="Text 9"/>
           <p:cNvSpPr/>
           <p:nvPr/>
         </p:nvSpPr>
@@ -2461,7 +2441,7 @@
       </p:sp>
       <p:sp>
         <p:nvSpPr>
-          <p:cNvPr id="13" name="Text 11"/>
+          <p:cNvPr id="12" name="Text 10"/>
           <p:cNvSpPr/>
           <p:nvPr/>
         </p:nvSpPr>
@@ -2489,7 +2469,7 @@
             <a:r>
               <a:rPr lang="en-US" sz="1500" b="1" dirty="0">
                 <a:solidFill>
-                  <a:srgbClr val="FFFFFF"/>
+                  <a:srgbClr val="16241A"/>
                 </a:solidFill>
                 <a:latin typeface="Calibri" pitchFamily="34" charset="0"/>
                 <a:ea typeface="Calibri" pitchFamily="34" charset="-122"/>
@@ -2507,7 +2487,7 @@
             <a:r>
               <a:rPr lang="en-US" sz="1300" dirty="0">
                 <a:solidFill>
-                  <a:srgbClr val="9FB396"/>
+                  <a:srgbClr val="5B6B57"/>
                 </a:solidFill>
                 <a:latin typeface="Calibri" pitchFamily="34" charset="0"/>
                 <a:ea typeface="Calibri" pitchFamily="34" charset="-122"/>
@@ -6482,7 +6462,7 @@
             </a:avLst>
           </a:prstGeom>
           <a:solidFill>
-            <a:srgbClr val="0E1C12"/>
+            <a:srgbClr val="1F5D33"/>
           </a:solidFill>
           <a:ln/>
           <a:effectLst>
@@ -8896,7 +8876,7 @@
     <p:bg>
       <p:bgPr>
         <a:solidFill>
-          <a:srgbClr val="0E1C12"/>
+          <a:srgbClr val="F4F7EF"/>
         </a:solidFill>
       </p:bgPr>
     </p:bg>
@@ -8922,14 +8902,14 @@
         </p:nvSpPr>
         <p:spPr>
           <a:xfrm>
-            <a:off x="9235440" y="-1737360"/>
-            <a:ext cx="5120640" cy="5120640"/>
+            <a:off x="10835640" y="5349240"/>
+            <a:ext cx="3200400" cy="3200400"/>
           </a:xfrm>
           <a:prstGeom prst="ellipse">
             <a:avLst/>
           </a:prstGeom>
           <a:solidFill>
-            <a:srgbClr val="1F5D33"/>
+            <a:srgbClr val="ECF3DF"/>
           </a:solidFill>
           <a:ln/>
         </p:spPr>
@@ -8942,14 +8922,14 @@
         </p:nvSpPr>
         <p:spPr>
           <a:xfrm>
-            <a:off x="10972800" y="2651760"/>
-            <a:ext cx="2011680" cy="2011680"/>
+            <a:off x="-868680" y="-868680"/>
+            <a:ext cx="2103120" cy="2103120"/>
           </a:xfrm>
           <a:prstGeom prst="ellipse">
             <a:avLst/>
           </a:prstGeom>
           <a:solidFill>
-            <a:srgbClr val="18301C"/>
+            <a:srgbClr val="EDF3E2"/>
           </a:solidFill>
           <a:ln/>
         </p:spPr>
@@ -8957,26 +8937,6 @@
       <p:sp>
         <p:nvSpPr>
           <p:cNvPr id="4" name="Shape 2"/>
-          <p:cNvSpPr/>
-          <p:nvPr/>
-        </p:nvSpPr>
-        <p:spPr>
-          <a:xfrm>
-            <a:off x="10195560" y="1600200"/>
-            <a:ext cx="457200" cy="457200"/>
-          </a:xfrm>
-          <a:prstGeom prst="ellipse">
-            <a:avLst/>
-          </a:prstGeom>
-          <a:solidFill>
-            <a:srgbClr val="B5E048"/>
-          </a:solidFill>
-          <a:ln/>
-        </p:spPr>
-      </p:sp>
-      <p:sp>
-        <p:nvSpPr>
-          <p:cNvPr id="5" name="Shape 3"/>
           <p:cNvSpPr/>
           <p:nvPr/>
         </p:nvSpPr>
@@ -8989,14 +8949,14 @@
             <a:avLst/>
           </a:prstGeom>
           <a:solidFill>
-            <a:srgbClr val="1F5D33"/>
-          </a:solidFill>
-          <a:ln/>
-        </p:spPr>
-      </p:sp>
-      <p:sp>
-        <p:nvSpPr>
-          <p:cNvPr id="6" name="Text 4"/>
+            <a:srgbClr val="E4EFD6"/>
+          </a:solidFill>
+          <a:ln/>
+        </p:spPr>
+      </p:sp>
+      <p:sp>
+        <p:nvSpPr>
+          <p:cNvPr id="5" name="Text 3"/>
           <p:cNvSpPr/>
           <p:nvPr/>
         </p:nvSpPr>
@@ -9032,7 +8992,7 @@
       </p:sp>
       <p:sp>
         <p:nvSpPr>
-          <p:cNvPr id="7" name="Text 5"/>
+          <p:cNvPr id="6" name="Text 4"/>
           <p:cNvSpPr/>
           <p:nvPr/>
         </p:nvSpPr>
@@ -9057,7 +9017,7 @@
             <a:r>
               <a:rPr lang="en-US" sz="4200" b="1" dirty="0">
                 <a:solidFill>
-                  <a:srgbClr val="FFFFFF"/>
+                  <a:srgbClr val="1F5D33"/>
                 </a:solidFill>
                 <a:latin typeface="Calibri" pitchFamily="34" charset="0"/>
                 <a:ea typeface="Calibri" pitchFamily="34" charset="-122"/>
@@ -9071,7 +9031,7 @@
       </p:sp>
       <p:sp>
         <p:nvSpPr>
-          <p:cNvPr id="8" name="Text 6"/>
+          <p:cNvPr id="7" name="Text 5"/>
           <p:cNvSpPr/>
           <p:nvPr/>
         </p:nvSpPr>
@@ -9096,7 +9056,7 @@
             <a:r>
               <a:rPr lang="en-US" sz="1800" dirty="0">
                 <a:solidFill>
-                  <a:srgbClr val="B5E048"/>
+                  <a:srgbClr val="2C6E3F"/>
                 </a:solidFill>
                 <a:latin typeface="Calibri" pitchFamily="34" charset="0"/>
                 <a:ea typeface="Calibri" pitchFamily="34" charset="-122"/>
@@ -9110,7 +9070,7 @@
       </p:sp>
       <p:sp>
         <p:nvSpPr>
-          <p:cNvPr id="9" name="Shape 7"/>
+          <p:cNvPr id="8" name="Shape 6"/>
           <p:cNvSpPr/>
           <p:nvPr/>
         </p:nvSpPr>
@@ -9132,7 +9092,7 @@
       </p:sp>
       <p:sp>
         <p:nvSpPr>
-          <p:cNvPr id="10" name="Text 8"/>
+          <p:cNvPr id="9" name="Text 7"/>
           <p:cNvSpPr/>
           <p:nvPr/>
         </p:nvSpPr>
@@ -9171,7 +9131,7 @@
       </p:sp>
       <p:sp>
         <p:nvSpPr>
-          <p:cNvPr id="11" name="Shape 9"/>
+          <p:cNvPr id="10" name="Shape 8"/>
           <p:cNvSpPr/>
           <p:nvPr/>
         </p:nvSpPr>
@@ -9193,7 +9153,7 @@
       </p:sp>
       <p:sp>
         <p:nvSpPr>
-          <p:cNvPr id="12" name="Text 10"/>
+          <p:cNvPr id="11" name="Text 9"/>
           <p:cNvSpPr/>
           <p:nvPr/>
         </p:nvSpPr>
@@ -9232,7 +9192,7 @@
       </p:sp>
       <p:sp>
         <p:nvSpPr>
-          <p:cNvPr id="13" name="Shape 11"/>
+          <p:cNvPr id="12" name="Shape 10"/>
           <p:cNvSpPr/>
           <p:nvPr/>
         </p:nvSpPr>
@@ -9254,7 +9214,7 @@
       </p:sp>
       <p:sp>
         <p:nvSpPr>
-          <p:cNvPr id="14" name="Text 12"/>
+          <p:cNvPr id="13" name="Text 11"/>
           <p:cNvSpPr/>
           <p:nvPr/>
         </p:nvSpPr>
@@ -9293,7 +9253,7 @@
       </p:sp>
       <p:sp>
         <p:nvSpPr>
-          <p:cNvPr id="15" name="Text 13"/>
+          <p:cNvPr id="14" name="Text 12"/>
           <p:cNvSpPr/>
           <p:nvPr/>
         </p:nvSpPr>
@@ -9321,7 +9281,7 @@
             <a:r>
               <a:rPr lang="en-US" sz="1400" b="1" dirty="0">
                 <a:solidFill>
-                  <a:srgbClr val="CBD8C2"/>
+                  <a:srgbClr val="16241A"/>
                 </a:solidFill>
                 <a:latin typeface="Calibri" pitchFamily="34" charset="0"/>
                 <a:ea typeface="Calibri" pitchFamily="34" charset="-122"/>
@@ -9339,7 +9299,7 @@
             <a:r>
               <a:rPr lang="en-US" sz="1250" dirty="0">
                 <a:solidFill>
-                  <a:srgbClr val="9FB396"/>
+                  <a:srgbClr val="5B6B57"/>
                 </a:solidFill>
                 <a:latin typeface="Calibri" pitchFamily="34" charset="0"/>
                 <a:ea typeface="Calibri" pitchFamily="34" charset="-122"/>
@@ -12210,7 +12170,7 @@
     <p:bg>
       <p:bgPr>
         <a:solidFill>
-          <a:srgbClr val="0E1C12"/>
+          <a:srgbClr val="F4F7EF"/>
         </a:solidFill>
       </p:bgPr>
     </p:bg>
@@ -12236,14 +12196,14 @@
         </p:nvSpPr>
         <p:spPr>
           <a:xfrm>
-            <a:off x="9235440" y="-1737360"/>
-            <a:ext cx="5120640" cy="5120640"/>
+            <a:off x="10835640" y="5349240"/>
+            <a:ext cx="3200400" cy="3200400"/>
           </a:xfrm>
           <a:prstGeom prst="ellipse">
             <a:avLst/>
           </a:prstGeom>
           <a:solidFill>
-            <a:srgbClr val="1F5D33"/>
+            <a:srgbClr val="ECF3DF"/>
           </a:solidFill>
           <a:ln/>
         </p:spPr>
@@ -12256,41 +12216,21 @@
         </p:nvSpPr>
         <p:spPr>
           <a:xfrm>
-            <a:off x="10972800" y="2651760"/>
-            <a:ext cx="2011680" cy="2011680"/>
+            <a:off x="-868680" y="-868680"/>
+            <a:ext cx="2103120" cy="2103120"/>
           </a:xfrm>
           <a:prstGeom prst="ellipse">
             <a:avLst/>
           </a:prstGeom>
           <a:solidFill>
-            <a:srgbClr val="18301C"/>
-          </a:solidFill>
-          <a:ln/>
-        </p:spPr>
-      </p:sp>
-      <p:sp>
-        <p:nvSpPr>
-          <p:cNvPr id="4" name="Shape 2"/>
-          <p:cNvSpPr/>
-          <p:nvPr/>
-        </p:nvSpPr>
-        <p:spPr>
-          <a:xfrm>
-            <a:off x="10195560" y="1600200"/>
-            <a:ext cx="457200" cy="457200"/>
-          </a:xfrm>
-          <a:prstGeom prst="ellipse">
-            <a:avLst/>
-          </a:prstGeom>
-          <a:solidFill>
-            <a:srgbClr val="B5E048"/>
-          </a:solidFill>
-          <a:ln/>
-        </p:spPr>
-      </p:sp>
-      <p:sp>
-        <p:nvSpPr>
-          <p:cNvPr id="5" name="Text 3"/>
+            <a:srgbClr val="EDF3E2"/>
+          </a:solidFill>
+          <a:ln/>
+        </p:spPr>
+      </p:sp>
+      <p:sp>
+        <p:nvSpPr>
+          <p:cNvPr id="4" name="Text 2"/>
           <p:cNvSpPr/>
           <p:nvPr/>
         </p:nvSpPr>
@@ -12315,7 +12255,7 @@
             <a:r>
               <a:rPr lang="en-US" sz="900" b="1" dirty="0">
                 <a:solidFill>
-                  <a:srgbClr val="B5E048"/>
+                  <a:srgbClr val="1F5D33"/>
                 </a:solidFill>
                 <a:latin typeface="Calibri" pitchFamily="34" charset="0"/>
                 <a:ea typeface="Calibri" pitchFamily="34" charset="-122"/>
@@ -12329,7 +12269,7 @@
             <a:r>
               <a:rPr lang="en-US" sz="900" dirty="0">
                 <a:solidFill>
-                  <a:srgbClr val="7C8E72"/>
+                  <a:srgbClr val="9AA892"/>
                 </a:solidFill>
                 <a:latin typeface="Calibri" pitchFamily="34" charset="0"/>
                 <a:ea typeface="Calibri" pitchFamily="34" charset="-122"/>
@@ -12343,7 +12283,7 @@
       </p:sp>
       <p:sp>
         <p:nvSpPr>
-          <p:cNvPr id="6" name="Text 4"/>
+          <p:cNvPr id="5" name="Text 3"/>
           <p:cNvSpPr/>
           <p:nvPr/>
         </p:nvSpPr>
@@ -12368,7 +12308,7 @@
             <a:r>
               <a:rPr lang="en-US" sz="900" dirty="0">
                 <a:solidFill>
-                  <a:srgbClr val="7C8E72"/>
+                  <a:srgbClr val="9AA892"/>
                 </a:solidFill>
                 <a:latin typeface="Calibri" pitchFamily="34" charset="0"/>
                 <a:ea typeface="Calibri" pitchFamily="34" charset="-122"/>
@@ -12382,7 +12322,7 @@
       </p:sp>
       <p:sp>
         <p:nvSpPr>
-          <p:cNvPr id="7" name="Shape 5"/>
+          <p:cNvPr id="6" name="Shape 4"/>
           <p:cNvSpPr/>
           <p:nvPr/>
         </p:nvSpPr>
@@ -12404,7 +12344,7 @@
       </p:sp>
       <p:sp>
         <p:nvSpPr>
-          <p:cNvPr id="8" name="Text 6"/>
+          <p:cNvPr id="7" name="Text 5"/>
           <p:cNvSpPr/>
           <p:nvPr/>
         </p:nvSpPr>
@@ -12443,7 +12383,7 @@
       </p:sp>
       <p:sp>
         <p:nvSpPr>
-          <p:cNvPr id="9" name="Text 7"/>
+          <p:cNvPr id="8" name="Text 6"/>
           <p:cNvSpPr/>
           <p:nvPr/>
         </p:nvSpPr>
@@ -12468,7 +12408,7 @@
             <a:r>
               <a:rPr lang="en-US" sz="3300" b="1" dirty="0">
                 <a:solidFill>
-                  <a:srgbClr val="FFFFFF"/>
+                  <a:srgbClr val="16241A"/>
                 </a:solidFill>
                 <a:latin typeface="Calibri" pitchFamily="34" charset="0"/>
                 <a:ea typeface="Calibri" pitchFamily="34" charset="-122"/>
@@ -12482,7 +12422,7 @@
       </p:sp>
       <p:sp>
         <p:nvSpPr>
-          <p:cNvPr id="10" name="Shape 8"/>
+          <p:cNvPr id="9" name="Shape 7"/>
           <p:cNvSpPr/>
           <p:nvPr/>
         </p:nvSpPr>
@@ -12511,7 +12451,7 @@
       </p:sp>
       <p:pic>
         <p:nvPicPr>
-          <p:cNvPr id="11" name="Image 0" descr="/tmp/claude-0/-home-user-kulpio/cf44c086-5ab5-569b-8ab9-43d11bcfa910/scratchpad/shots/scard.png">    </p:cNvPr>
+          <p:cNvPr id="10" name="Image 0" descr="/tmp/claude-0/-home-user-kulpio/cf44c086-5ab5-569b-8ab9-43d11bcfa910/scratchpad/shots/ls-scan.png">    </p:cNvPr>
           <p:cNvPicPr>
             <a:picLocks noChangeAspect="1"/>
           </p:cNvPicPr>
@@ -12535,7 +12475,7 @@
       </p:pic>
       <p:sp>
         <p:nvSpPr>
-          <p:cNvPr id="12" name="Shape 9"/>
+          <p:cNvPr id="11" name="Shape 8"/>
           <p:cNvSpPr/>
           <p:nvPr/>
         </p:nvSpPr>
@@ -12564,7 +12504,7 @@
       </p:sp>
       <p:pic>
         <p:nvPicPr>
-          <p:cNvPr id="13" name="Image 1" descr="/tmp/claude-0/-home-user-kulpio/cf44c086-5ab5-569b-8ab9-43d11bcfa910/scratchpad/shots/impact.png">    </p:cNvPr>
+          <p:cNvPr id="12" name="Image 1" descr="/tmp/claude-0/-home-user-kulpio/cf44c086-5ab5-569b-8ab9-43d11bcfa910/scratchpad/shots/ls-impact.png">    </p:cNvPr>
           <p:cNvPicPr>
             <a:picLocks noChangeAspect="1"/>
           </p:cNvPicPr>
@@ -12588,7 +12528,7 @@
       </p:pic>
       <p:sp>
         <p:nvSpPr>
-          <p:cNvPr id="14" name="Shape 10"/>
+          <p:cNvPr id="13" name="Shape 9"/>
           <p:cNvSpPr/>
           <p:nvPr/>
         </p:nvSpPr>
@@ -12617,7 +12557,7 @@
       </p:sp>
       <p:pic>
         <p:nvPicPr>
-          <p:cNvPr id="15" name="Image 2" descr="/tmp/claude-0/-home-user-kulpio/cf44c086-5ab5-569b-8ab9-43d11bcfa910/scratchpad/shots/chat.png">    </p:cNvPr>
+          <p:cNvPr id="14" name="Image 2" descr="/tmp/claude-0/-home-user-kulpio/cf44c086-5ab5-569b-8ab9-43d11bcfa910/scratchpad/shots/ls-discover.png">    </p:cNvPr>
           <p:cNvPicPr>
             <a:picLocks noChangeAspect="1"/>
           </p:cNvPicPr>
@@ -12641,7 +12581,7 @@
       </p:pic>
       <p:sp>
         <p:nvSpPr>
-          <p:cNvPr id="16" name="Text 11"/>
+          <p:cNvPr id="15" name="Text 10"/>
           <p:cNvSpPr/>
           <p:nvPr/>
         </p:nvSpPr>
@@ -12666,7 +12606,7 @@
             <a:r>
               <a:rPr lang="en-US" sz="1300" b="1" dirty="0">
                 <a:solidFill>
-                  <a:srgbClr val="FFFFFF"/>
+                  <a:srgbClr val="16241A"/>
                 </a:solidFill>
                 <a:latin typeface="Calibri" pitchFamily="34" charset="0"/>
                 <a:ea typeface="Calibri" pitchFamily="34" charset="-122"/>
@@ -12681,13 +12621,13 @@
             <a:r>
               <a:rPr lang="en-US" sz="1100" dirty="0">
                 <a:solidFill>
-                  <a:srgbClr val="9FB396"/>
-                </a:solidFill>
-                <a:latin typeface="Calibri" pitchFamily="34" charset="0"/>
-                <a:ea typeface="Calibri" pitchFamily="34" charset="-122"/>
-                <a:cs typeface="Calibri" pitchFamily="34" charset="-120"/>
-              </a:rPr>
-              <a:t>additives, Nutri-Score, verdict</a:t>
+                  <a:srgbClr val="5B6B57"/>
+                </a:solidFill>
+                <a:latin typeface="Calibri" pitchFamily="34" charset="0"/>
+                <a:ea typeface="Calibri" pitchFamily="34" charset="-122"/>
+                <a:cs typeface="Calibri" pitchFamily="34" charset="-120"/>
+              </a:rPr>
+              <a:t>Nutri-Score, allergens, verdict</a:t>
             </a:r>
             <a:endParaRPr lang="en-US" sz="1300" dirty="0"/>
           </a:p>
@@ -12695,7 +12635,7 @@
       </p:sp>
       <p:sp>
         <p:nvSpPr>
-          <p:cNvPr id="17" name="Text 12"/>
+          <p:cNvPr id="16" name="Text 11"/>
           <p:cNvSpPr/>
           <p:nvPr/>
         </p:nvSpPr>
@@ -12720,7 +12660,7 @@
             <a:r>
               <a:rPr lang="en-US" sz="1300" b="1" dirty="0">
                 <a:solidFill>
-                  <a:srgbClr val="FFFFFF"/>
+                  <a:srgbClr val="16241A"/>
                 </a:solidFill>
                 <a:latin typeface="Calibri" pitchFamily="34" charset="0"/>
                 <a:ea typeface="Calibri" pitchFamily="34" charset="-122"/>
@@ -12735,7 +12675,7 @@
             <a:r>
               <a:rPr lang="en-US" sz="1100" dirty="0">
                 <a:solidFill>
-                  <a:srgbClr val="9FB396"/>
+                  <a:srgbClr val="5B6B57"/>
                 </a:solidFill>
                 <a:latin typeface="Calibri" pitchFamily="34" charset="0"/>
                 <a:ea typeface="Calibri" pitchFamily="34" charset="-122"/>
@@ -12749,7 +12689,7 @@
       </p:sp>
       <p:sp>
         <p:nvSpPr>
-          <p:cNvPr id="18" name="Text 13"/>
+          <p:cNvPr id="17" name="Text 12"/>
           <p:cNvSpPr/>
           <p:nvPr/>
         </p:nvSpPr>
@@ -12774,13 +12714,13 @@
             <a:r>
               <a:rPr lang="en-US" sz="1300" b="1" dirty="0">
                 <a:solidFill>
-                  <a:srgbClr val="FFFFFF"/>
-                </a:solidFill>
-                <a:latin typeface="Calibri" pitchFamily="34" charset="0"/>
-                <a:ea typeface="Calibri" pitchFamily="34" charset="-122"/>
-                <a:cs typeface="Calibri" pitchFamily="34" charset="-120"/>
-              </a:rPr>
-              <a:t>Shared fridge
+                  <a:srgbClr val="16241A"/>
+                </a:solidFill>
+                <a:latin typeface="Calibri" pitchFamily="34" charset="0"/>
+                <a:ea typeface="Calibri" pitchFamily="34" charset="-122"/>
+                <a:cs typeface="Calibri" pitchFamily="34" charset="-120"/>
+              </a:rPr>
+              <a:t>Discover
 </a:t>
             </a:r>
             <a:pPr algn="ctr" indent="0" marL="0">
@@ -12789,13 +12729,13 @@
             <a:r>
               <a:rPr lang="en-US" sz="1100" dirty="0">
                 <a:solidFill>
-                  <a:srgbClr val="9FB396"/>
-                </a:solidFill>
-                <a:latin typeface="Calibri" pitchFamily="34" charset="0"/>
-                <a:ea typeface="Calibri" pitchFamily="34" charset="-122"/>
-                <a:cs typeface="Calibri" pitchFamily="34" charset="-120"/>
-              </a:rPr>
-              <a:t>members, activity &amp; chat</a:t>
+                  <a:srgbClr val="5B6B57"/>
+                </a:solidFill>
+                <a:latin typeface="Calibri" pitchFamily="34" charset="0"/>
+                <a:ea typeface="Calibri" pitchFamily="34" charset="-122"/>
+                <a:cs typeface="Calibri" pitchFamily="34" charset="-120"/>
+              </a:rPr>
+              <a:t>what the community scans</a:t>
             </a:r>
             <a:endParaRPr lang="en-US" sz="1300" dirty="0"/>
           </a:p>
@@ -12815,7 +12755,7 @@
     <p:bg>
       <p:bgPr>
         <a:solidFill>
-          <a:srgbClr val="0E1C12"/>
+          <a:srgbClr val="F4F7EF"/>
         </a:solidFill>
       </p:bgPr>
     </p:bg>
@@ -12841,14 +12781,14 @@
         </p:nvSpPr>
         <p:spPr>
           <a:xfrm>
-            <a:off x="9235440" y="-1737360"/>
-            <a:ext cx="5120640" cy="5120640"/>
+            <a:off x="10835640" y="5349240"/>
+            <a:ext cx="3200400" cy="3200400"/>
           </a:xfrm>
           <a:prstGeom prst="ellipse">
             <a:avLst/>
           </a:prstGeom>
           <a:solidFill>
-            <a:srgbClr val="1F5D33"/>
+            <a:srgbClr val="ECF3DF"/>
           </a:solidFill>
           <a:ln/>
         </p:spPr>
@@ -12861,41 +12801,21 @@
         </p:nvSpPr>
         <p:spPr>
           <a:xfrm>
-            <a:off x="10972800" y="2651760"/>
-            <a:ext cx="2011680" cy="2011680"/>
+            <a:off x="-868680" y="-868680"/>
+            <a:ext cx="2103120" cy="2103120"/>
           </a:xfrm>
           <a:prstGeom prst="ellipse">
             <a:avLst/>
           </a:prstGeom>
           <a:solidFill>
-            <a:srgbClr val="18301C"/>
-          </a:solidFill>
-          <a:ln/>
-        </p:spPr>
-      </p:sp>
-      <p:sp>
-        <p:nvSpPr>
-          <p:cNvPr id="4" name="Shape 2"/>
-          <p:cNvSpPr/>
-          <p:nvPr/>
-        </p:nvSpPr>
-        <p:spPr>
-          <a:xfrm>
-            <a:off x="10195560" y="1600200"/>
-            <a:ext cx="457200" cy="457200"/>
-          </a:xfrm>
-          <a:prstGeom prst="ellipse">
-            <a:avLst/>
-          </a:prstGeom>
-          <a:solidFill>
-            <a:srgbClr val="B5E048"/>
-          </a:solidFill>
-          <a:ln/>
-        </p:spPr>
-      </p:sp>
-      <p:sp>
-        <p:nvSpPr>
-          <p:cNvPr id="5" name="Text 3"/>
+            <a:srgbClr val="EDF3E2"/>
+          </a:solidFill>
+          <a:ln/>
+        </p:spPr>
+      </p:sp>
+      <p:sp>
+        <p:nvSpPr>
+          <p:cNvPr id="4" name="Text 2"/>
           <p:cNvSpPr/>
           <p:nvPr/>
         </p:nvSpPr>
@@ -12920,7 +12840,7 @@
             <a:r>
               <a:rPr lang="en-US" sz="900" b="1" dirty="0">
                 <a:solidFill>
-                  <a:srgbClr val="B5E048"/>
+                  <a:srgbClr val="1F5D33"/>
                 </a:solidFill>
                 <a:latin typeface="Calibri" pitchFamily="34" charset="0"/>
                 <a:ea typeface="Calibri" pitchFamily="34" charset="-122"/>
@@ -12934,7 +12854,7 @@
             <a:r>
               <a:rPr lang="en-US" sz="900" dirty="0">
                 <a:solidFill>
-                  <a:srgbClr val="7C8E72"/>
+                  <a:srgbClr val="9AA892"/>
                 </a:solidFill>
                 <a:latin typeface="Calibri" pitchFamily="34" charset="0"/>
                 <a:ea typeface="Calibri" pitchFamily="34" charset="-122"/>
@@ -12948,7 +12868,7 @@
       </p:sp>
       <p:sp>
         <p:nvSpPr>
-          <p:cNvPr id="6" name="Text 4"/>
+          <p:cNvPr id="5" name="Text 3"/>
           <p:cNvSpPr/>
           <p:nvPr/>
         </p:nvSpPr>
@@ -12973,7 +12893,7 @@
             <a:r>
               <a:rPr lang="en-US" sz="900" dirty="0">
                 <a:solidFill>
-                  <a:srgbClr val="7C8E72"/>
+                  <a:srgbClr val="9AA892"/>
                 </a:solidFill>
                 <a:latin typeface="Calibri" pitchFamily="34" charset="0"/>
                 <a:ea typeface="Calibri" pitchFamily="34" charset="-122"/>
@@ -12987,7 +12907,7 @@
       </p:sp>
       <p:sp>
         <p:nvSpPr>
-          <p:cNvPr id="7" name="Shape 5"/>
+          <p:cNvPr id="6" name="Shape 4"/>
           <p:cNvSpPr/>
           <p:nvPr/>
         </p:nvSpPr>
@@ -13009,7 +12929,7 @@
       </p:sp>
       <p:sp>
         <p:nvSpPr>
-          <p:cNvPr id="8" name="Text 6"/>
+          <p:cNvPr id="7" name="Text 5"/>
           <p:cNvSpPr/>
           <p:nvPr/>
         </p:nvSpPr>
@@ -13048,7 +12968,7 @@
       </p:sp>
       <p:sp>
         <p:nvSpPr>
-          <p:cNvPr id="9" name="Text 7"/>
+          <p:cNvPr id="8" name="Text 6"/>
           <p:cNvSpPr/>
           <p:nvPr/>
         </p:nvSpPr>
@@ -13073,7 +12993,7 @@
             <a:r>
               <a:rPr lang="en-US" sz="3300" b="1" dirty="0">
                 <a:solidFill>
-                  <a:srgbClr val="FFFFFF"/>
+                  <a:srgbClr val="16241A"/>
                 </a:solidFill>
                 <a:latin typeface="Calibri" pitchFamily="34" charset="0"/>
                 <a:ea typeface="Calibri" pitchFamily="34" charset="-122"/>
@@ -13087,7 +13007,7 @@
       </p:sp>
       <p:sp>
         <p:nvSpPr>
-          <p:cNvPr id="10" name="Shape 8"/>
+          <p:cNvPr id="9" name="Shape 7"/>
           <p:cNvSpPr/>
           <p:nvPr/>
         </p:nvSpPr>
@@ -13116,7 +13036,7 @@
       </p:sp>
       <p:pic>
         <p:nvPicPr>
-          <p:cNvPr id="11" name="Image 0" descr="/tmp/claude-0/-home-user-kulpio/cf44c086-5ab5-569b-8ab9-43d11bcfa910/scratchpad/shots/big-home.png">    </p:cNvPr>
+          <p:cNvPr id="10" name="Image 0" descr="/tmp/claude-0/-home-user-kulpio/cf44c086-5ab5-569b-8ab9-43d11bcfa910/scratchpad/shots/ls-home.png">    </p:cNvPr>
           <p:cNvPicPr>
             <a:picLocks noChangeAspect="1"/>
           </p:cNvPicPr>
@@ -13140,7 +13060,7 @@
       </p:pic>
       <p:sp>
         <p:nvSpPr>
-          <p:cNvPr id="12" name="Text 9"/>
+          <p:cNvPr id="11" name="Text 8"/>
           <p:cNvSpPr/>
           <p:nvPr/>
         </p:nvSpPr>
@@ -13165,7 +13085,7 @@
             <a:r>
               <a:rPr lang="en-US" sz="1200" b="1" dirty="0">
                 <a:solidFill>
-                  <a:srgbClr val="FFFFFF"/>
+                  <a:srgbClr val="16241A"/>
                 </a:solidFill>
                 <a:latin typeface="Calibri" pitchFamily="34" charset="0"/>
                 <a:ea typeface="Calibri" pitchFamily="34" charset="-122"/>
@@ -13180,7 +13100,7 @@
             <a:r>
               <a:rPr lang="en-US" sz="1000" dirty="0">
                 <a:solidFill>
-                  <a:srgbClr val="9FB396"/>
+                  <a:srgbClr val="5B6B57"/>
                 </a:solidFill>
                 <a:latin typeface="Calibri" pitchFamily="34" charset="0"/>
                 <a:ea typeface="Calibri" pitchFamily="34" charset="-122"/>
@@ -13194,7 +13114,7 @@
       </p:sp>
       <p:sp>
         <p:nvSpPr>
-          <p:cNvPr id="13" name="Shape 10"/>
+          <p:cNvPr id="12" name="Shape 9"/>
           <p:cNvSpPr/>
           <p:nvPr/>
         </p:nvSpPr>
@@ -13223,7 +13143,7 @@
       </p:sp>
       <p:pic>
         <p:nvPicPr>
-          <p:cNvPr id="14" name="Image 1" descr="/tmp/claude-0/-home-user-kulpio/cf44c086-5ab5-569b-8ab9-43d11bcfa910/scratchpad/shots/house.png">    </p:cNvPr>
+          <p:cNvPr id="13" name="Image 1" descr="/tmp/claude-0/-home-user-kulpio/cf44c086-5ab5-569b-8ab9-43d11bcfa910/scratchpad/shots/ls-recipes.png">    </p:cNvPr>
           <p:cNvPicPr>
             <a:picLocks noChangeAspect="1"/>
           </p:cNvPicPr>
@@ -13247,7 +13167,7 @@
       </p:pic>
       <p:sp>
         <p:nvSpPr>
-          <p:cNvPr id="15" name="Text 11"/>
+          <p:cNvPr id="14" name="Text 10"/>
           <p:cNvSpPr/>
           <p:nvPr/>
         </p:nvSpPr>
@@ -13272,13 +13192,13 @@
             <a:r>
               <a:rPr lang="en-US" sz="1200" b="1" dirty="0">
                 <a:solidFill>
-                  <a:srgbClr val="FFFFFF"/>
-                </a:solidFill>
-                <a:latin typeface="Calibri" pitchFamily="34" charset="0"/>
-                <a:ea typeface="Calibri" pitchFamily="34" charset="-122"/>
-                <a:cs typeface="Calibri" pitchFamily="34" charset="-120"/>
-              </a:rPr>
-              <a:t>Shared fridge
+                  <a:srgbClr val="16241A"/>
+                </a:solidFill>
+                <a:latin typeface="Calibri" pitchFamily="34" charset="0"/>
+                <a:ea typeface="Calibri" pitchFamily="34" charset="-122"/>
+                <a:cs typeface="Calibri" pitchFamily="34" charset="-120"/>
+              </a:rPr>
+              <a:t>Recipes
 </a:t>
             </a:r>
             <a:pPr algn="ctr" indent="0" marL="0">
@@ -13287,13 +13207,13 @@
             <a:r>
               <a:rPr lang="en-US" sz="1000" dirty="0">
                 <a:solidFill>
-                  <a:srgbClr val="9FB396"/>
-                </a:solidFill>
-                <a:latin typeface="Calibri" pitchFamily="34" charset="0"/>
-                <a:ea typeface="Calibri" pitchFamily="34" charset="-122"/>
-                <a:cs typeface="Calibri" pitchFamily="34" charset="-120"/>
-              </a:rPr>
-              <a:t>one code links your household</a:t>
+                  <a:srgbClr val="5B6B57"/>
+                </a:solidFill>
+                <a:latin typeface="Calibri" pitchFamily="34" charset="0"/>
+                <a:ea typeface="Calibri" pitchFamily="34" charset="-122"/>
+                <a:cs typeface="Calibri" pitchFamily="34" charset="-120"/>
+              </a:rPr>
+              <a:t>cook from what you have</a:t>
             </a:r>
             <a:endParaRPr lang="en-US" sz="1200" dirty="0"/>
           </a:p>
@@ -13301,7 +13221,7 @@
       </p:sp>
       <p:sp>
         <p:nvSpPr>
-          <p:cNvPr id="16" name="Shape 12"/>
+          <p:cNvPr id="15" name="Shape 11"/>
           <p:cNvSpPr/>
           <p:nvPr/>
         </p:nvSpPr>
@@ -13330,7 +13250,7 @@
       </p:sp>
       <p:pic>
         <p:nvPicPr>
-          <p:cNvPr id="17" name="Image 2" descr="/tmp/claude-0/-home-user-kulpio/cf44c086-5ab5-569b-8ab9-43d11bcfa910/scratchpad/shots/gdpr.png">    </p:cNvPr>
+          <p:cNvPr id="16" name="Image 2" descr="/tmp/claude-0/-home-user-kulpio/cf44c086-5ab5-569b-8ab9-43d11bcfa910/scratchpad/shots/light-detail.png">    </p:cNvPr>
           <p:cNvPicPr>
             <a:picLocks noChangeAspect="1"/>
           </p:cNvPicPr>
@@ -13354,7 +13274,7 @@
       </p:pic>
       <p:sp>
         <p:nvSpPr>
-          <p:cNvPr id="18" name="Text 13"/>
+          <p:cNvPr id="17" name="Text 12"/>
           <p:cNvSpPr/>
           <p:nvPr/>
         </p:nvSpPr>
@@ -13379,13 +13299,13 @@
             <a:r>
               <a:rPr lang="en-US" sz="1200" b="1" dirty="0">
                 <a:solidFill>
-                  <a:srgbClr val="FFFFFF"/>
-                </a:solidFill>
-                <a:latin typeface="Calibri" pitchFamily="34" charset="0"/>
-                <a:ea typeface="Calibri" pitchFamily="34" charset="-122"/>
-                <a:cs typeface="Calibri" pitchFamily="34" charset="-120"/>
-              </a:rPr>
-              <a:t>Your data
+                  <a:srgbClr val="16241A"/>
+                </a:solidFill>
+                <a:latin typeface="Calibri" pitchFamily="34" charset="0"/>
+                <a:ea typeface="Calibri" pitchFamily="34" charset="-122"/>
+                <a:cs typeface="Calibri" pitchFamily="34" charset="-120"/>
+              </a:rPr>
+              <a:t>Every item, one tap
 </a:t>
             </a:r>
             <a:pPr algn="ctr" indent="0" marL="0">
@@ -13394,13 +13314,13 @@
             <a:r>
               <a:rPr lang="en-US" sz="1000" dirty="0">
                 <a:solidFill>
-                  <a:srgbClr val="9FB396"/>
-                </a:solidFill>
-                <a:latin typeface="Calibri" pitchFamily="34" charset="0"/>
-                <a:ea typeface="Calibri" pitchFamily="34" charset="-122"/>
-                <a:cs typeface="Calibri" pitchFamily="34" charset="-120"/>
-              </a:rPr>
-              <a:t>export or delete anytime</a:t>
+                  <a:srgbClr val="5B6B57"/>
+                </a:solidFill>
+                <a:latin typeface="Calibri" pitchFamily="34" charset="0"/>
+                <a:ea typeface="Calibri" pitchFamily="34" charset="-122"/>
+                <a:cs typeface="Calibri" pitchFamily="34" charset="-120"/>
+              </a:rPr>
+              <a:t>edit, price history, storage</a:t>
             </a:r>
             <a:endParaRPr lang="en-US" sz="1200" dirty="0"/>
           </a:p>
@@ -13408,7 +13328,7 @@
       </p:sp>
       <p:sp>
         <p:nvSpPr>
-          <p:cNvPr id="19" name="Shape 14"/>
+          <p:cNvPr id="18" name="Shape 13"/>
           <p:cNvSpPr/>
           <p:nvPr/>
         </p:nvSpPr>
@@ -13437,7 +13357,7 @@
       </p:sp>
       <p:pic>
         <p:nvPicPr>
-          <p:cNvPr id="20" name="Image 3" descr="/tmp/claude-0/-home-user-kulpio/cf44c086-5ab5-569b-8ab9-43d11bcfa910/scratchpad/shots/profile-full.png">    </p:cNvPr>
+          <p:cNvPr id="19" name="Image 3" descr="/tmp/claude-0/-home-user-kulpio/cf44c086-5ab5-569b-8ab9-43d11bcfa910/scratchpad/shots/ls-profile.png">    </p:cNvPr>
           <p:cNvPicPr>
             <a:picLocks noChangeAspect="1"/>
           </p:cNvPicPr>
@@ -13461,7 +13381,7 @@
       </p:pic>
       <p:sp>
         <p:nvSpPr>
-          <p:cNvPr id="21" name="Text 15"/>
+          <p:cNvPr id="20" name="Text 14"/>
           <p:cNvSpPr/>
           <p:nvPr/>
         </p:nvSpPr>
@@ -13486,7 +13406,7 @@
             <a:r>
               <a:rPr lang="en-US" sz="1200" b="1" dirty="0">
                 <a:solidFill>
-                  <a:srgbClr val="FFFFFF"/>
+                  <a:srgbClr val="16241A"/>
                 </a:solidFill>
                 <a:latin typeface="Calibri" pitchFamily="34" charset="0"/>
                 <a:ea typeface="Calibri" pitchFamily="34" charset="-122"/>
@@ -13501,7 +13421,7 @@
             <a:r>
               <a:rPr lang="en-US" sz="1000" dirty="0">
                 <a:solidFill>
-                  <a:srgbClr val="9FB396"/>
+                  <a:srgbClr val="5B6B57"/>
                 </a:solidFill>
                 <a:latin typeface="Calibri" pitchFamily="34" charset="0"/>
                 <a:ea typeface="Calibri" pitchFamily="34" charset="-122"/>
@@ -17181,7 +17101,7 @@
             </a:avLst>
           </a:prstGeom>
           <a:solidFill>
-            <a:srgbClr val="0E1C12"/>
+            <a:srgbClr val="1F5D33"/>
           </a:solidFill>
           <a:ln/>
           <a:effectLst>

</xml_diff>